<commit_message>
Retitle domain seminar decks to match course syllabus
Updates each deck's title slide, notes, file name and the folder
README to the syllabus domain seminar titles.

Co-Authored-By: Claude Opus 5.5 <noreply@anthropic.com>
Claude-Session: https://claude.ai/code/session_01XYJ4xmrADRJAP7ufCAYieX
</commit_message>
<xml_diff>
--- a/domain-seminars/week05_value_based_payment.pptx
+++ b/domain-seminars/week05_value_based_payment.pptx
@@ -506,7 +506,7 @@
           <a:lstStyle/>
           <a:p>
             <a:r>
-              <a:t>Domain seminar for week 5: Value-Based Payment and Attribution. It follows the course pattern: basics and terminology, where the topic sits in industry and policy, reform goals, how analytics is deployed, and how analytics drives decisions. Replace this note with your own opening remarks.</a:t>
+              <a:t>Domain seminar for week 5: Value Based Payment Current State. It follows the course pattern: basics and terminology, where the topic sits in industry and policy, reform goals, how analytics is deployed, and how analytics drives decisions. Replace this note with your own opening remarks.</a:t>
             </a:r>
           </a:p>
         </p:txBody>
@@ -1506,7 +1506,7 @@
 </p:sldMaster>
 </file>
 
-<file path=ppt/slides/slide11.xml><?xml version="1.0" encoding="utf-8"?>
+<file path=ppt/slides/slide1.xml><?xml version="1.0" encoding="utf-8"?>
 <p:sld xmlns:a="http://schemas.openxmlformats.org/drawingml/2006/main" xmlns:p="http://schemas.openxmlformats.org/presentationml/2006/main" xmlns:r="http://schemas.openxmlformats.org/officeDocument/2006/relationships">
   <p:cSld>
     <p:spTree>
@@ -1548,7 +1548,7 @@
                   <a:srgbClr val="FFFFFF"/>
                 </a:solidFill>
               </a:rPr>
-              <a:t>Value-Based Payment and Attribution</a:t>
+              <a:t>Value Based Payment Current State</a:t>
             </a:r>
             <a:endParaRPr lang="en-US" sz="4000" dirty="0"/>
           </a:p>
@@ -1600,7 +1600,7 @@
 </p:sld>
 </file>
 
-<file path=ppt/slides/slide12.xml><?xml version="1.0" encoding="utf-8"?>
+<file path=ppt/slides/slide2.xml><?xml version="1.0" encoding="utf-8"?>
 <p:sld xmlns:a="http://schemas.openxmlformats.org/drawingml/2006/main" xmlns:p="http://schemas.openxmlformats.org/presentationml/2006/main" xmlns:r="http://schemas.openxmlformats.org/officeDocument/2006/relationships">
   <p:cSld>
     <p:spTree>
@@ -1797,7 +1797,7 @@
 </p:sld>
 </file>
 
-<file path=ppt/slides/slide13.xml><?xml version="1.0" encoding="utf-8"?>
+<file path=ppt/slides/slide3.xml><?xml version="1.0" encoding="utf-8"?>
 <p:sld xmlns:a="http://schemas.openxmlformats.org/drawingml/2006/main" xmlns:p="http://schemas.openxmlformats.org/presentationml/2006/main" xmlns:r="http://schemas.openxmlformats.org/officeDocument/2006/relationships">
   <p:cSld>
     <p:spTree>
@@ -1994,7 +1994,7 @@
 </p:sld>
 </file>
 
-<file path=ppt/slides/slide14.xml><?xml version="1.0" encoding="utf-8"?>
+<file path=ppt/slides/slide4.xml><?xml version="1.0" encoding="utf-8"?>
 <p:sld xmlns:a="http://schemas.openxmlformats.org/drawingml/2006/main" xmlns:p="http://schemas.openxmlformats.org/presentationml/2006/main" xmlns:r="http://schemas.openxmlformats.org/officeDocument/2006/relationships">
   <p:cSld>
     <p:spTree>
@@ -2191,7 +2191,7 @@
 </p:sld>
 </file>
 
-<file path=ppt/slides/slide15.xml><?xml version="1.0" encoding="utf-8"?>
+<file path=ppt/slides/slide5.xml><?xml version="1.0" encoding="utf-8"?>
 <p:sld xmlns:a="http://schemas.openxmlformats.org/drawingml/2006/main" xmlns:p="http://schemas.openxmlformats.org/presentationml/2006/main" xmlns:r="http://schemas.openxmlformats.org/officeDocument/2006/relationships">
   <p:cSld>
     <p:spTree>
@@ -2388,7 +2388,7 @@
 </p:sld>
 </file>
 
-<file path=ppt/slides/slide16.xml><?xml version="1.0" encoding="utf-8"?>
+<file path=ppt/slides/slide6.xml><?xml version="1.0" encoding="utf-8"?>
 <p:sld xmlns:a="http://schemas.openxmlformats.org/drawingml/2006/main" xmlns:p="http://schemas.openxmlformats.org/presentationml/2006/main" xmlns:r="http://schemas.openxmlformats.org/officeDocument/2006/relationships">
   <p:cSld>
     <p:spTree>

</xml_diff>